<commit_message>
docs: sync lecture 1 tech news, add tech news to lecture 2
</commit_message>
<xml_diff>
--- a/lecture-1.pptx
+++ b/lecture-1.pptx
@@ -2,25 +2,25 @@
 <file path=ppt/presentation.xml><?xml version="1.0" encoding="utf-8"?>
 <p:presentation xmlns:a="http://schemas.openxmlformats.org/drawingml/2006/main" xmlns:r="http://schemas.openxmlformats.org/officeDocument/2006/relationships" xmlns:mc="http://schemas.openxmlformats.org/markup-compatibility/2006" xmlns:mv="urn:schemas-microsoft-com:mac:vml" xmlns:p="http://schemas.openxmlformats.org/presentationml/2006/main" xmlns:c="http://schemas.openxmlformats.org/drawingml/2006/chart" xmlns:dgm="http://schemas.openxmlformats.org/drawingml/2006/diagram" xmlns:o="urn:schemas-microsoft-com:office:office" xmlns:v="urn:schemas-microsoft-com:vml" xmlns:pvml="urn:schemas-microsoft-com:office:powerpoint" xmlns:com="http://schemas.openxmlformats.org/drawingml/2006/compatibility" xmlns:p14="http://schemas.microsoft.com/office/powerpoint/2010/main" xmlns:p15="http://schemas.microsoft.com/office/powerpoint/2012/main" xmlns:ahyp="http://schemas.microsoft.com/office/drawing/2018/hyperlinkcolor" autoCompressPictures="0" strictFirstAndLastChars="0" saveSubsetFonts="1">
   <p:sldMasterIdLst>
-    <p:sldMasterId id="2147483670" r:id="rId4"/>
-    <p:sldMasterId id="2147483671" r:id="rId5"/>
+    <p:sldMasterId id="2147483670" r:id="rId5"/>
+    <p:sldMasterId id="2147483671" r:id="rId6"/>
   </p:sldMasterIdLst>
   <p:notesMasterIdLst>
-    <p:notesMasterId r:id="rId6"/>
+    <p:notesMasterId r:id="rId7"/>
   </p:notesMasterIdLst>
   <p:sldIdLst>
-    <p:sldId id="256" r:id="rId7"/>
-    <p:sldId id="257" r:id="rId8"/>
-    <p:sldId id="258" r:id="rId9"/>
-    <p:sldId id="259" r:id="rId10"/>
-    <p:sldId id="260" r:id="rId11"/>
-    <p:sldId id="261" r:id="rId12"/>
-    <p:sldId id="262" r:id="rId13"/>
-    <p:sldId id="263" r:id="rId14"/>
-    <p:sldId id="264" r:id="rId15"/>
-    <p:sldId id="265" r:id="rId16"/>
-    <p:sldId id="266" r:id="rId17"/>
-    <p:sldId id="267" r:id="rId18"/>
+    <p:sldId id="256" r:id="rId8"/>
+    <p:sldId id="257" r:id="rId9"/>
+    <p:sldId id="258" r:id="rId10"/>
+    <p:sldId id="259" r:id="rId11"/>
+    <p:sldId id="260" r:id="rId12"/>
+    <p:sldId id="261" r:id="rId13"/>
+    <p:sldId id="262" r:id="rId14"/>
+    <p:sldId id="263" r:id="rId15"/>
+    <p:sldId id="264" r:id="rId16"/>
+    <p:sldId id="265" r:id="rId17"/>
+    <p:sldId id="266" r:id="rId18"/>
+    <p:sldId id="267" r:id="rId19"/>
   </p:sldIdLst>
   <p:sldSz cy="8572500" cx="5715000"/>
   <p:notesSz cx="6858000" cy="9144000"/>
@@ -275,6 +275,28 @@
     </p:ext>
   </p:extLst>
 </p:presentation>
+</file>
+
+<file path=ppt/commentAuthors.xml><?xml version="1.0" encoding="utf-8"?>
+<p:cmAuthorLst xmlns:a="http://schemas.openxmlformats.org/drawingml/2006/main" xmlns:r="http://schemas.openxmlformats.org/officeDocument/2006/relationships" xmlns:mc="http://schemas.openxmlformats.org/markup-compatibility/2006" xmlns:mv="urn:schemas-microsoft-com:mac:vml" xmlns:p="http://schemas.openxmlformats.org/presentationml/2006/main" xmlns:c="http://schemas.openxmlformats.org/drawingml/2006/chart" xmlns:dgm="http://schemas.openxmlformats.org/drawingml/2006/diagram" xmlns:o="urn:schemas-microsoft-com:office:office" xmlns:v="urn:schemas-microsoft-com:vml" xmlns:pvml="urn:schemas-microsoft-com:office:powerpoint" xmlns:com="http://schemas.openxmlformats.org/drawingml/2006/compatibility" xmlns:p14="http://schemas.microsoft.com/office/powerpoint/2010/main" xmlns:p15="http://schemas.microsoft.com/office/powerpoint/2012/main" xmlns:ahyp="http://schemas.microsoft.com/office/drawing/2018/hyperlinkcolor">
+  <p:cmAuthor clrIdx="0" id="0" initials="" lastIdx="2" name="Mani Gh"/>
+</p:cmAuthorLst>
+</file>
+
+<file path=ppt/comments/comment1.xml><?xml version="1.0" encoding="utf-8"?>
+<p:cmLst xmlns:a="http://schemas.openxmlformats.org/drawingml/2006/main" xmlns:r="http://schemas.openxmlformats.org/officeDocument/2006/relationships" xmlns:mc="http://schemas.openxmlformats.org/markup-compatibility/2006" xmlns:mv="urn:schemas-microsoft-com:mac:vml" xmlns:p="http://schemas.openxmlformats.org/presentationml/2006/main" xmlns:c="http://schemas.openxmlformats.org/drawingml/2006/chart" xmlns:dgm="http://schemas.openxmlformats.org/drawingml/2006/diagram" xmlns:o="urn:schemas-microsoft-com:office:office" xmlns:v="urn:schemas-microsoft-com:vml" xmlns:pvml="urn:schemas-microsoft-com:office:powerpoint" xmlns:com="http://schemas.openxmlformats.org/drawingml/2006/compatibility" xmlns:p14="http://schemas.microsoft.com/office/powerpoint/2010/main" xmlns:p15="http://schemas.microsoft.com/office/powerpoint/2012/main" xmlns:ahyp="http://schemas.microsoft.com/office/drawing/2018/hyperlinkcolor">
+  <p:cm authorId="0" idx="1" dt="2026-09-20T12:45:22.580">
+    <p:pos x="6000" y="0"/>
+    <p:text>Do the same thing in second week @mani.ghahremani@port.ac.uk
+_Assigned to mani.ghahremani@port.ac.uk_</p:text>
+  </p:cm>
+  <p:cm authorId="0" idx="2" dt="2026-09-20T12:51:27.130">
+    <p:pos x="340" y="907"/>
+    <p:text>Refer to auto completion as Intellisense (auto complete drop down, types methods, params) vs ghost text.
+@mani.ghahremani@port.ac.uk
+_Assigned to mani.ghahremani@port.ac.uk_</p:text>
+  </p:cm>
+</p:cmLst>
 </file>
 
 <file path=ppt/notesMasters/notesMaster1.xml><?xml version="1.0" encoding="utf-8"?>
@@ -12731,7 +12753,7 @@
         <p:spPr>
           <a:xfrm>
             <a:off x="540000" y="1440000"/>
-            <a:ext cx="5175000" cy="4748400"/>
+            <a:ext cx="5175000" cy="5141100"/>
           </a:xfrm>
           <a:prstGeom prst="rect">
             <a:avLst/>
@@ -12884,16 +12906,16 @@
                   <a:schemeClr val="dk1"/>
                 </a:solidFill>
               </a:rPr>
-              <a:t>To get started, Flutter blog: </a:t>
+              <a:t>VS Code intro: </a:t>
             </a:r>
             <a:r>
               <a:rPr lang="en-GB" sz="1700" u="sng">
                 <a:solidFill>
                   <a:schemeClr val="hlink"/>
                 </a:solidFill>
-                <a:hlinkClick r:id="rId3"/>
+                <a:hlinkClick r:id="rId4"/>
               </a:rPr>
-              <a:t>medium.com/flutter</a:t>
+              <a:t>youtube.com/watch?v=f8_uF_IDV50</a:t>
             </a:r>
             <a:endParaRPr sz="1700">
               <a:solidFill>
@@ -12931,7 +12953,7 @@
                 <a:solidFill>
                   <a:schemeClr val="hlink"/>
                 </a:solidFill>
-                <a:hlinkClick r:id="rId4"/>
+                <a:hlinkClick r:id="rId5"/>
               </a:rPr>
               <a:t>github.com/trending</a:t>
             </a:r>
@@ -12971,7 +12993,7 @@
                 <a:solidFill>
                   <a:schemeClr val="hlink"/>
                 </a:solidFill>
-                <a:hlinkClick r:id="rId5"/>
+                <a:hlinkClick r:id="rId6"/>
               </a:rPr>
               <a:t>youtube.com/playlist?list=PLjxrf2q8roU23XGwz3Km7sQZFTdB996iG</a:t>
             </a:r>
@@ -14880,9 +14902,9 @@
 </file>
 
 <file path=ppt/theme/theme1.xml><?xml version="1.0" encoding="utf-8"?>
-<a:theme xmlns:a="http://schemas.openxmlformats.org/drawingml/2006/main" xmlns:r="http://schemas.openxmlformats.org/officeDocument/2006/relationships" name="Simple Light">
+<a:theme xmlns:a="http://schemas.openxmlformats.org/drawingml/2006/main" xmlns:r="http://schemas.openxmlformats.org/officeDocument/2006/relationships">
   <a:themeElements>
-    <a:clrScheme name="Simple Light">
+    <a:clrScheme name="Default">
       <a:dk1>
         <a:srgbClr val="000000"/>
       </a:dk1>
@@ -14890,34 +14912,34 @@
         <a:srgbClr val="FFFFFF"/>
       </a:lt1>
       <a:dk2>
-        <a:srgbClr val="595959"/>
+        <a:srgbClr val="158158"/>
       </a:dk2>
       <a:lt2>
-        <a:srgbClr val="EEEEEE"/>
+        <a:srgbClr val="F3F3F3"/>
       </a:lt2>
       <a:accent1>
-        <a:srgbClr val="FFAB40"/>
+        <a:srgbClr val="058DC7"/>
       </a:accent1>
       <a:accent2>
-        <a:srgbClr val="212121"/>
+        <a:srgbClr val="50B432"/>
       </a:accent2>
       <a:accent3>
-        <a:srgbClr val="FF5733"/>
+        <a:srgbClr val="ED561B"/>
       </a:accent3>
       <a:accent4>
-        <a:srgbClr val="34D1BF"/>
+        <a:srgbClr val="EDEF00"/>
       </a:accent4>
       <a:accent5>
-        <a:srgbClr val="F9E79F"/>
+        <a:srgbClr val="24CBE5"/>
       </a:accent5>
       <a:accent6>
-        <a:srgbClr val="EEFF41"/>
+        <a:srgbClr val="64E572"/>
       </a:accent6>
       <a:hlink>
-        <a:srgbClr val="0097A7"/>
+        <a:srgbClr val="2200CC"/>
       </a:hlink>
       <a:folHlink>
-        <a:srgbClr val="0097A7"/>
+        <a:srgbClr val="551A8B"/>
       </a:folHlink>
     </a:clrScheme>
     <a:fontScheme name="Office">
@@ -15438,9 +15460,9 @@
 </file>
 
 <file path=ppt/theme/theme3.xml><?xml version="1.0" encoding="utf-8"?>
-<a:theme xmlns:a="http://schemas.openxmlformats.org/drawingml/2006/main" xmlns:r="http://schemas.openxmlformats.org/officeDocument/2006/relationships">
+<a:theme xmlns:a="http://schemas.openxmlformats.org/drawingml/2006/main" xmlns:r="http://schemas.openxmlformats.org/officeDocument/2006/relationships" name="Simple Light">
   <a:themeElements>
-    <a:clrScheme name="Default">
+    <a:clrScheme name="Simple Light">
       <a:dk1>
         <a:srgbClr val="000000"/>
       </a:dk1>
@@ -15448,34 +15470,34 @@
         <a:srgbClr val="FFFFFF"/>
       </a:lt1>
       <a:dk2>
-        <a:srgbClr val="158158"/>
+        <a:srgbClr val="595959"/>
       </a:dk2>
       <a:lt2>
-        <a:srgbClr val="F3F3F3"/>
+        <a:srgbClr val="EEEEEE"/>
       </a:lt2>
       <a:accent1>
-        <a:srgbClr val="058DC7"/>
+        <a:srgbClr val="FFAB40"/>
       </a:accent1>
       <a:accent2>
-        <a:srgbClr val="50B432"/>
+        <a:srgbClr val="212121"/>
       </a:accent2>
       <a:accent3>
-        <a:srgbClr val="ED561B"/>
+        <a:srgbClr val="FF5733"/>
       </a:accent3>
       <a:accent4>
-        <a:srgbClr val="EDEF00"/>
+        <a:srgbClr val="34D1BF"/>
       </a:accent4>
       <a:accent5>
-        <a:srgbClr val="24CBE5"/>
+        <a:srgbClr val="F9E79F"/>
       </a:accent5>
       <a:accent6>
-        <a:srgbClr val="64E572"/>
+        <a:srgbClr val="EEFF41"/>
       </a:accent6>
       <a:hlink>
-        <a:srgbClr val="2200CC"/>
+        <a:srgbClr val="0097A7"/>
       </a:hlink>
       <a:folHlink>
-        <a:srgbClr val="551A8B"/>
+        <a:srgbClr val="0097A7"/>
       </a:folHlink>
     </a:clrScheme>
     <a:fontScheme name="Office">

</xml_diff>